<commit_message>
Transfer deck for Adam: Janzen's role accounts, Dan deploys every update; Wednesday brief and pack updated
Co-Authored-By: Claude Opus 5.5 <noreply@anthropic.com>
Claude-Session: https://claude.ai/code/session_01Nu3pab9XPV8qshuLn85v3c
</commit_message>
<xml_diff>
--- a/SACRED-TRANSFER-DECK-2026-10.pptx
+++ b/SACRED-TRANSFER-DECK-2026-10.pptx
@@ -2538,6 +2538,10 @@
             <a:prstDash val="solid"/>
           </a:ln>
         </p:spPr>
+        <p:txBody>
+          <a:bodyPr/>
+          <a:p/>
+        </p:txBody>
       </p:sp>
       <p:sp>
         <p:nvSpPr>
@@ -2637,6 +2641,10 @@
             <a:prstDash val="solid"/>
           </a:ln>
         </p:spPr>
+        <p:txBody>
+          <a:bodyPr/>
+          <a:p/>
+        </p:txBody>
       </p:sp>
       <p:sp>
         <p:nvSpPr>
@@ -2736,6 +2744,10 @@
             <a:prstDash val="solid"/>
           </a:ln>
         </p:spPr>
+        <p:txBody>
+          <a:bodyPr/>
+          <a:p/>
+        </p:txBody>
       </p:sp>
       <p:sp>
         <p:nvSpPr>
@@ -2943,6 +2955,10 @@
             <a:prstDash val="solid"/>
           </a:ln>
         </p:spPr>
+        <p:txBody>
+          <a:bodyPr/>
+          <a:p/>
+        </p:txBody>
       </p:sp>
       <p:sp>
         <p:nvSpPr>
@@ -3042,6 +3058,10 @@
             <a:prstDash val="solid"/>
           </a:ln>
         </p:spPr>
+        <p:txBody>
+          <a:bodyPr/>
+          <a:p/>
+        </p:txBody>
       </p:sp>
       <p:sp>
         <p:nvSpPr>
@@ -3141,6 +3161,10 @@
             <a:prstDash val="solid"/>
           </a:ln>
         </p:spPr>
+        <p:txBody>
+          <a:bodyPr/>
+          <a:p/>
+        </p:txBody>
       </p:sp>
       <p:sp>
         <p:nvSpPr>
@@ -3240,6 +3264,10 @@
             <a:prstDash val="solid"/>
           </a:ln>
         </p:spPr>
+        <p:txBody>
+          <a:bodyPr/>
+          <a:p/>
+        </p:txBody>
       </p:sp>
       <p:sp>
         <p:nvSpPr>
@@ -3447,6 +3475,10 @@
             <a:prstDash val="solid"/>
           </a:ln>
         </p:spPr>
+        <p:txBody>
+          <a:bodyPr/>
+          <a:p/>
+        </p:txBody>
       </p:sp>
       <p:sp>
         <p:nvSpPr>
@@ -3514,7 +3546,7 @@
                   <a:schemeClr val="tx1"/>
                 </a:solidFill>
               </a:rPr>
-              <a:t>Identity created and tested: can it read PostedReports and write the web folder? WCEMPD mailbox requested.</a:t>
+              <a:t>Identity created and tested: can it read PostedReports and write the web folder? Well Control Group role accounts requested by Janzen (17 Oct).</a:t>
             </a:r>
             <a:endParaRPr lang="en-US" sz="1400" dirty="0"/>
           </a:p>
@@ -3546,6 +3578,10 @@
             <a:prstDash val="solid"/>
           </a:ln>
         </p:spPr>
+        <p:txBody>
+          <a:bodyPr/>
+          <a:p/>
+        </p:txBody>
       </p:sp>
       <p:sp>
         <p:nvSpPr>
@@ -3645,6 +3681,10 @@
             <a:prstDash val="solid"/>
           </a:ln>
         </p:spPr>
+        <p:txBody>
+          <a:bodyPr/>
+          <a:p/>
+        </p:txBody>
       </p:sp>
       <p:sp>
         <p:nvSpPr>
@@ -3744,6 +3784,10 @@
             <a:prstDash val="solid"/>
           </a:ln>
         </p:spPr>
+        <p:txBody>
+          <a:bodyPr/>
+          <a:p/>
+        </p:txBody>
       </p:sp>
       <p:sp>
         <p:nvSpPr>
@@ -3843,6 +3887,10 @@
             <a:prstDash val="solid"/>
           </a:ln>
         </p:spPr>
+        <p:txBody>
+          <a:bodyPr/>
+          <a:p/>
+        </p:txBody>
       </p:sp>
       <p:sp>
         <p:nvSpPr>
@@ -3942,6 +3990,10 @@
             <a:prstDash val="solid"/>
           </a:ln>
         </p:spPr>
+        <p:txBody>
+          <a:bodyPr/>
+          <a:p/>
+        </p:txBody>
       </p:sp>
       <p:sp>
         <p:nvSpPr>
@@ -4009,7 +4061,7 @@
                   <a:schemeClr val="tx1"/>
                 </a:solidFill>
               </a:rPr>
-              <a:t>Lee's drop folder, the extract library, HTTPS check from a rig tablet, WCEMPD swapped into the flows.</a:t>
+              <a:t>Dan's deploy access confirmed, the extract library, HTTPS check from a rig tablet, the role accounts swapped into the flows.</a:t>
             </a:r>
             <a:endParaRPr lang="en-US" sz="1400" dirty="0"/>
           </a:p>
@@ -4175,7 +4227,7 @@
                   <a:schemeClr val="accent3"/>
                 </a:solidFill>
               </a:rPr>
-              <a:t>2  Who creates the identity (service account or app registration) and by when</a:t>
+              <a:t>2  The identity: Janzen's two role accounts (requested 17 Oct). Confirm one runs the scanner, or an app registration as well</a:t>
             </a:r>
             <a:endParaRPr lang="en-US" sz="2000" dirty="0"/>
           </a:p>
@@ -4192,7 +4244,7 @@
                   <a:schemeClr val="accent3"/>
                 </a:solidFill>
               </a:rPr>
-              <a:t>3  The WCEMPD mailbox and its three licences</a:t>
+              <a:t>3  The role accounts' Exchange, Power Automate and Teams licences, and who owns them</a:t>
             </a:r>
             <a:endParaRPr lang="en-US" sz="2000" dirty="0"/>
           </a:p>
@@ -4223,7 +4275,7 @@
                   <a:schemeClr val="accent3"/>
                 </a:solidFill>
               </a:rPr>
-              <a:t>5  Later, not today: eDocs connector owner, Fabric capacity</a:t>
+              <a:t>5  Later, not today: eDocs connector API key (asked of Digital Desk, 17 Oct; Dan's account until the role accounts land), Fabric capacity</a:t>
             </a:r>
             <a:endParaRPr lang="en-US" sz="2000" dirty="0"/>
           </a:p>
@@ -4318,6 +4370,10 @@
             <a:prstDash val="solid"/>
           </a:ln>
         </p:spPr>
+        <p:txBody>
+          <a:bodyPr/>
+          <a:p/>
+        </p:txBody>
       </p:sp>
       <p:sp>
         <p:nvSpPr>
@@ -4417,6 +4473,10 @@
             <a:prstDash val="solid"/>
           </a:ln>
         </p:spPr>
+        <p:txBody>
+          <a:bodyPr/>
+          <a:p/>
+        </p:txBody>
       </p:sp>
       <p:sp>
         <p:nvSpPr>
@@ -4516,6 +4576,10 @@
             <a:prstDash val="solid"/>
           </a:ln>
         </p:spPr>
+        <p:txBody>
+          <a:bodyPr/>
+          <a:p/>
+        </p:txBody>
       </p:sp>
       <p:sp>
         <p:nvSpPr>
@@ -4583,7 +4647,7 @@
                   <a:schemeClr val="tx1"/>
                 </a:solidFill>
               </a:rPr>
-              <a:t>Posting from the rigs since August. 428 reports on the server. Nine automation loops. Database export for Fabric every run.</a:t>
+              <a:t>Posting from the rigs since August. About 400 reports on the server. Nine automation loops. Database export for Fabric every run (36 tables).</a:t>
             </a:r>
             <a:endParaRPr lang="en-US" sz="1300" dirty="0"/>
           </a:p>
@@ -4666,7 +4730,7 @@
                   <a:schemeClr val="accent1"/>
                 </a:solidFill>
               </a:rPr>
-              <a:t>Ask of this meeting: pick the host, agree the identities, book the transfer day.</a:t>
+              <a:t>Ask of this meeting: pick the host, confirm the identities Janzen has requested, book the transfer day.</a:t>
             </a:r>
             <a:endParaRPr lang="en-US" sz="1600" dirty="0"/>
           </a:p>
@@ -4806,6 +4870,10 @@
             <a:prstDash val="solid"/>
           </a:ln>
         </p:spPr>
+        <p:txBody>
+          <a:bodyPr/>
+          <a:p/>
+        </p:txBody>
       </p:sp>
       <p:sp>
         <p:nvSpPr>
@@ -4905,6 +4973,10 @@
             <a:prstDash val="solid"/>
           </a:ln>
         </p:spPr>
+        <p:txBody>
+          <a:bodyPr/>
+          <a:p/>
+        </p:txBody>
       </p:sp>
       <p:sp>
         <p:nvSpPr>
@@ -5004,6 +5076,10 @@
             <a:prstDash val="solid"/>
           </a:ln>
         </p:spPr>
+        <p:txBody>
+          <a:bodyPr/>
+          <a:p/>
+        </p:txBody>
       </p:sp>
       <p:sp>
         <p:nvSpPr>
@@ -5103,6 +5179,10 @@
             <a:prstDash val="solid"/>
           </a:ln>
         </p:spPr>
+        <p:txBody>
+          <a:bodyPr/>
+          <a:p/>
+        </p:txBody>
       </p:sp>
       <p:sp>
         <p:nvSpPr>
@@ -5202,6 +5282,10 @@
             <a:prstDash val="solid"/>
           </a:ln>
         </p:spPr>
+        <p:txBody>
+          <a:bodyPr/>
+          <a:p/>
+        </p:txBody>
       </p:sp>
       <p:sp>
         <p:nvSpPr>
@@ -5301,6 +5385,10 @@
             <a:prstDash val="solid"/>
           </a:ln>
         </p:spPr>
+        <p:txBody>
+          <a:bodyPr/>
+          <a:p/>
+        </p:txBody>
       </p:sp>
       <p:sp>
         <p:nvSpPr>
@@ -5398,6 +5486,10 @@
             <a:prstDash val="solid"/>
           </a:ln>
         </p:spPr>
+        <p:txBody>
+          <a:bodyPr/>
+          <a:p/>
+        </p:txBody>
       </p:sp>
       <p:sp>
         <p:nvSpPr>
@@ -5589,6 +5681,10 @@
             <a:prstDash val="solid"/>
           </a:ln>
         </p:spPr>
+        <p:txBody>
+          <a:bodyPr/>
+          <a:p/>
+        </p:txBody>
       </p:sp>
       <p:sp>
         <p:nvSpPr>
@@ -5703,6 +5799,10 @@
             <a:prstDash val="solid"/>
           </a:ln>
         </p:spPr>
+        <p:txBody>
+          <a:bodyPr/>
+          <a:p/>
+        </p:txBody>
       </p:sp>
       <p:sp>
         <p:nvSpPr>
@@ -5817,6 +5917,10 @@
             <a:prstDash val="solid"/>
           </a:ln>
         </p:spPr>
+        <p:txBody>
+          <a:bodyPr/>
+          <a:p/>
+        </p:txBody>
       </p:sp>
       <p:sp>
         <p:nvSpPr>
@@ -5931,6 +6035,10 @@
             <a:prstDash val="solid"/>
           </a:ln>
         </p:spPr>
+        <p:txBody>
+          <a:bodyPr/>
+          <a:p/>
+        </p:txBody>
       </p:sp>
       <p:sp>
         <p:nvSpPr>
@@ -6045,6 +6153,10 @@
             <a:prstDash val="solid"/>
           </a:ln>
         </p:spPr>
+        <p:txBody>
+          <a:bodyPr/>
+          <a:p/>
+        </p:txBody>
       </p:sp>
       <p:sp>
         <p:nvSpPr>
@@ -6159,6 +6271,10 @@
             <a:prstDash val="solid"/>
           </a:ln>
         </p:spPr>
+        <p:txBody>
+          <a:bodyPr/>
+          <a:p/>
+        </p:txBody>
       </p:sp>
       <p:sp>
         <p:nvSpPr>
@@ -6273,6 +6389,10 @@
             <a:prstDash val="solid"/>
           </a:ln>
         </p:spPr>
+        <p:txBody>
+          <a:bodyPr/>
+          <a:p/>
+        </p:txBody>
       </p:sp>
       <p:sp>
         <p:nvSpPr>
@@ -6357,7 +6477,7 @@
                   <a:schemeClr val="tx2"/>
                 </a:solidFill>
               </a:rPr>
-              <a:t>34 tables, 21,500 rows every run, ready for Fabric.</a:t>
+              <a:t>36 tables, 22,600 rows every run, ready for Fabric.</a:t>
             </a:r>
             <a:endParaRPr lang="en-US" sz="1500" dirty="0"/>
           </a:p>
@@ -6387,6 +6507,10 @@
             <a:prstDash val="solid"/>
           </a:ln>
         </p:spPr>
+        <p:txBody>
+          <a:bodyPr/>
+          <a:p/>
+        </p:txBody>
       </p:sp>
       <p:sp>
         <p:nvSpPr>
@@ -6827,6 +6951,10 @@
             <a:prstDash val="solid"/>
           </a:ln>
         </p:spPr>
+        <p:txBody>
+          <a:bodyPr/>
+          <a:p/>
+        </p:txBody>
       </p:sp>
       <p:sp>
         <p:nvSpPr>
@@ -7034,6 +7162,10 @@
             <a:prstDash val="solid"/>
           </a:ln>
         </p:spPr>
+        <p:txBody>
+          <a:bodyPr/>
+          <a:p/>
+        </p:txBody>
       </p:sp>
       <p:sp>
         <p:nvSpPr>
@@ -7101,7 +7233,7 @@
                   <a:schemeClr val="tx1"/>
                 </a:solidFill>
               </a:rPr>
-              <a:t>Reads the SharePoint library and writes the web folder. A service account or an app registration. Today it is Dan's login.</a:t>
+              <a:t>Reads the SharePoint library and writes the web folder. Today it is Dan's login. Janzen Small (ISIT, Tech Services' app IT contact) requested two role accounts on 17 Oct: Well Control Group 1 and 2.</a:t>
             </a:r>
             <a:endParaRPr lang="en-US" sz="1300" dirty="0"/>
           </a:p>
@@ -7133,6 +7265,10 @@
             <a:prstDash val="solid"/>
           </a:ln>
         </p:spPr>
+        <p:txBody>
+          <a:bodyPr/>
+          <a:p/>
+        </p:txBody>
       </p:sp>
       <p:sp>
         <p:nvSpPr>
@@ -7232,6 +7368,10 @@
             <a:prstDash val="solid"/>
           </a:ln>
         </p:spPr>
+        <p:txBody>
+          <a:bodyPr/>
+          <a:p/>
+        </p:txBody>
       </p:sp>
       <p:sp>
         <p:nvSpPr>
@@ -7331,6 +7471,10 @@
             <a:prstDash val="solid"/>
           </a:ln>
         </p:spPr>
+        <p:txBody>
+          <a:bodyPr/>
+          <a:p/>
+        </p:txBody>
       </p:sp>
       <p:sp>
         <p:nvSpPr>
@@ -7362,7 +7506,7 @@
                   <a:schemeClr val="accent1"/>
                 </a:solidFill>
               </a:rPr>
-              <a:t>The WCEMPD mailbox</a:t>
+              <a:t>Role accounts and mailbox</a:t>
             </a:r>
             <a:endParaRPr lang="en-US" sz="1600" dirty="0"/>
           </a:p>
@@ -7398,7 +7542,7 @@
                   <a:schemeClr val="tx1"/>
                 </a:solidFill>
               </a:rPr>
-              <a:t>Exchange, Power Automate and Teams licences, so every email and Teams post comes from the department, not from Dan.</a:t>
+              <a:t>The Well Control Group accounts with Exchange, Power Automate and Teams licences, so emails and Teams posts come from the department, not Dan, and access survives rotations and shared tablets.</a:t>
             </a:r>
             <a:endParaRPr lang="en-US" sz="1300" dirty="0"/>
           </a:p>
@@ -7430,6 +7574,10 @@
             <a:prstDash val="solid"/>
           </a:ln>
         </p:spPr>
+        <p:txBody>
+          <a:bodyPr/>
+          <a:p/>
+        </p:txBody>
       </p:sp>
       <p:sp>
         <p:nvSpPr>
@@ -7529,6 +7677,10 @@
             <a:prstDash val="solid"/>
           </a:ln>
         </p:spPr>
+        <p:txBody>
+          <a:bodyPr/>
+          <a:p/>
+        </p:txBody>
       </p:sp>
       <p:sp>
         <p:nvSpPr>
@@ -7560,7 +7712,7 @@
                   <a:schemeClr val="accent1"/>
                 </a:solidFill>
               </a:rPr>
-              <a:t>A drop folder for Lee</a:t>
+              <a:t>Dan deploys every update</a:t>
             </a:r>
             <a:endParaRPr lang="en-US" sz="1600" dirty="0"/>
           </a:p>
@@ -7596,7 +7748,7 @@
                   <a:schemeClr val="tx1"/>
                 </a:solidFill>
               </a:rPr>
-              <a:t>Argo Navis is Lee's build; he needs to put a new revision on the host without a ticket each time.</a:t>
+              <a:t>Dan drops every update himself (scanner, Argo Navis, precharge, pages): Lee sends his Argo Navis builds to Dan. Dan's write access to the deploy folders means no ticket per update.</a:t>
             </a:r>
             <a:endParaRPr lang="en-US" sz="1300" dirty="0"/>
           </a:p>
@@ -7736,6 +7888,10 @@
             <a:prstDash val="solid"/>
           </a:ln>
         </p:spPr>
+        <p:txBody>
+          <a:bodyPr/>
+          <a:p/>
+        </p:txBody>
       </p:sp>
       <p:sp>
         <p:nvSpPr>
@@ -7894,7 +8050,7 @@
                   <a:schemeClr val="tx1"/>
                 </a:solidFill>
               </a:rPr>
-              <a:t>Share access for Lee</a:t>
+              <a:t>Write access for Dan to the deploy folders</a:t>
             </a:r>
             <a:endParaRPr lang="en-US" sz="1400" dirty="0"/>
           </a:p>
@@ -7926,6 +8082,10 @@
             <a:prstDash val="solid"/>
           </a:ln>
         </p:spPr>
+        <p:txBody>
+          <a:bodyPr/>
+          <a:p/>
+        </p:txBody>
       </p:sp>
       <p:sp>
         <p:nvSpPr>
@@ -8025,6 +8185,10 @@
             <a:prstDash val="solid"/>
           </a:ln>
         </p:spPr>
+        <p:txBody>
+          <a:bodyPr/>
+          <a:p/>
+        </p:txBody>
       </p:sp>
       <p:sp>
         <p:nvSpPr>
@@ -8232,6 +8396,10 @@
             <a:prstDash val="solid"/>
           </a:ln>
         </p:spPr>
+        <p:txBody>
+          <a:bodyPr/>
+          <a:p/>
+        </p:txBody>
       </p:sp>
       <p:sp>
         <p:nvSpPr>
@@ -8404,6 +8572,10 @@
             <a:prstDash val="solid"/>
           </a:ln>
         </p:spPr>
+        <p:txBody>
+          <a:bodyPr/>
+          <a:p/>
+        </p:txBody>
       </p:sp>
       <p:sp>
         <p:nvSpPr>
@@ -8503,6 +8675,10 @@
             <a:prstDash val="solid"/>
           </a:ln>
         </p:spPr>
+        <p:txBody>
+          <a:bodyPr/>
+          <a:p/>
+        </p:txBody>
       </p:sp>
       <p:sp>
         <p:nvSpPr>

</xml_diff>

<commit_message>
Fabric not approved (Janzen, 17 Oct): data moves to Power BI Pro; plan, database plan, transfer deck, Wednesday brief, pack updated
Co-Authored-By: Claude Opus 5.5 <noreply@anthropic.com>
Claude-Session: https://claude.ai/code/session_01Nu3pab9XPV8qshuLn85v3c
</commit_message>
<xml_diff>
--- a/SACRED-TRANSFER-DECK-2026-10.pptx
+++ b/SACRED-TRANSFER-DECK-2026-10.pptx
@@ -4275,7 +4275,7 @@
                   <a:schemeClr val="accent3"/>
                 </a:solidFill>
               </a:rPr>
-              <a:t>5  Later, not today: eDocs connector API key (asked of Digital Desk, 17 Oct; Dan's account until the role accounts land), Fabric capacity</a:t>
+              <a:t>5  Later, not today: eDocs connector API key (asked of Digital Desk, 17 Oct; Dan's account until the role accounts land), Power BI Pro workspace for the data (Fabric not approved, 17 Oct)</a:t>
             </a:r>
             <a:endParaRPr lang="en-US" sz="2000" dirty="0"/>
           </a:p>
@@ -4647,7 +4647,7 @@
                   <a:schemeClr val="tx1"/>
                 </a:solidFill>
               </a:rPr>
-              <a:t>Posting from the rigs since August. About 400 reports on the server. Nine automation loops. Database export for Fabric every run (36 tables).</a:t>
+              <a:t>Posting from the rigs since August. About 400 reports on the server. Nine automation loops. Database export every run (36 tables), read by Power BI.</a:t>
             </a:r>
             <a:endParaRPr lang="en-US" sz="1300" dirty="0"/>
           </a:p>
@@ -6477,7 +6477,7 @@
                   <a:schemeClr val="tx2"/>
                 </a:solidFill>
               </a:rPr>
-              <a:t>36 tables, 22,600 rows every run, ready for Fabric.</a:t>
+              <a:t>36 tables, 22,600 rows every run, read by Power BI Pro (Fabric is not an approved platform).</a:t>
             </a:r>
             <a:endParaRPr lang="en-US" sz="1500" dirty="0"/>
           </a:p>

</xml_diff>